<commit_message>
fix: close Phase 1 vertical slice review gaps
</commit_message>
<xml_diff>
--- a/thesis-deck-system/artifacts/phase1/master_first_build.pptx
+++ b/thesis-deck-system/artifacts/phase1/master_first_build.pptx
@@ -3758,21 +3758,43 @@
           <a:lstStyle/>
           <a:p>
             <a:r>
-              <a:t>Synthetic fixture • photo_observation</a:t>
-            </a:r>
-          </a:p>
-          <a:p>
-            <a:r>
-              <a:t>Claim: C001</a:t>
-            </a:r>
-          </a:p>
-          <a:p>
-            <a:r>
-              <a:t>Evidence: E001</a:t>
-            </a:r>
-          </a:p>
-        </p:txBody>
-      </p:sp>
+              <a:rPr sz="1800"/>
+              <a:t>Synthetic microscopy: defect density varies by position.</a:t>
+            </a:r>
+          </a:p>
+          <a:p/>
+          <a:p>
+            <a:r>
+              <a:rPr sz="1800"/>
+              <a:t>Test transport versus boundary accumulation.</a:t>
+            </a:r>
+          </a:p>
+        </p:txBody>
+      </p:sp>
+      <p:pic>
+        <p:nvPicPr>
+          <p:cNvPr id="4" name="Picture 3" descr="observation_visual.png"/>
+          <p:cNvPicPr>
+            <a:picLocks noChangeAspect="1"/>
+          </p:cNvPicPr>
+          <p:nvPr/>
+        </p:nvPicPr>
+        <p:blipFill>
+          <a:blip r:embed="rId2"/>
+          <a:stretch>
+            <a:fillRect/>
+          </a:stretch>
+        </p:blipFill>
+        <p:spPr>
+          <a:xfrm>
+            <a:off x="6035040" y="1463040"/>
+            <a:ext cx="5303520" cy="3017520"/>
+          </a:xfrm>
+          <a:prstGeom prst="rect">
+            <a:avLst/>
+          </a:prstGeom>
+        </p:spPr>
+      </p:pic>
     </p:spTree>
   </p:cSld>
   <p:clrMapOvr>
@@ -3826,45 +3848,35 @@
         <p:txBody>
           <a:bodyPr/>
           <a:lstStyle/>
-          <a:p/>
-        </p:txBody>
-      </p:sp>
-      <p:sp>
-        <p:nvSpPr>
-          <p:cNvPr id="4" name="TextBox 3"/>
-          <p:cNvSpPr txBox="1"/>
-          <p:nvPr/>
-        </p:nvSpPr>
-        <p:spPr>
-          <a:xfrm>
-            <a:off x="640080" y="1828800"/>
-            <a:ext cx="3657600" cy="1828800"/>
-          </a:xfrm>
-          <a:prstGeom prst="rect">
-            <a:avLst/>
-          </a:prstGeom>
-          <a:noFill/>
-        </p:spPr>
-        <p:txBody>
-          <a:bodyPr wrap="none">
-            <a:spAutoFit/>
-          </a:bodyPr>
-          <a:lstStyle/>
-          <a:p>
-            <a:r>
-              <a:t>Claim: C001</a:t>
-            </a:r>
-          </a:p>
-          <a:p>
-            <a:r>
-              <a:t>Evidence: E001</a:t>
+          <a:p>
+            <a:r>
+              <a:rPr sz="1600"/>
+              <a:t>Result / Discussion</a:t>
+            </a:r>
+          </a:p>
+          <a:p>
+            <a:r>
+              <a:rPr sz="1600"/>
+              <a:t>Trend supports transport, but boundary effects remain unresolved.</a:t>
+            </a:r>
+          </a:p>
+          <a:p>
+            <a:r>
+              <a:rPr sz="1600"/>
+              <a:t>Decision: Partial-Go: add control</a:t>
+            </a:r>
+          </a:p>
+          <a:p>
+            <a:r>
+              <a:rPr sz="1600"/>
+              <a:t>Next Step: Tracer control; researcher; due 2026-09-02</a:t>
             </a:r>
           </a:p>
         </p:txBody>
       </p:sp>
       <p:pic>
         <p:nvPicPr>
-          <p:cNvPr id="5" name="Picture 4" descr="B001_defect_density.png"/>
+          <p:cNvPr id="4" name="Picture 3" descr="B001_defect_density.png"/>
           <p:cNvPicPr>
             <a:picLocks noChangeAspect="1"/>
           </p:cNvPicPr>

</xml_diff>

<commit_message>
fix: satisfy Phase 1 revision 2 blockers
</commit_message>
<xml_diff>
--- a/thesis-deck-system/artifacts/phase1/master_first_build.pptx
+++ b/thesis-deck-system/artifacts/phase1/master_first_build.pptx
@@ -3756,24 +3756,48 @@
         <p:txBody>
           <a:bodyPr/>
           <a:lstStyle/>
+          <a:p/>
+        </p:txBody>
+      </p:sp>
+      <p:sp>
+        <p:nvSpPr>
+          <p:cNvPr id="4" name="TextBox 3"/>
+          <p:cNvSpPr txBox="1"/>
+          <p:nvPr/>
+        </p:nvSpPr>
+        <p:spPr>
+          <a:xfrm>
+            <a:off x="640080" y="1554480"/>
+            <a:ext cx="5120640" cy="3474720"/>
+          </a:xfrm>
+          <a:prstGeom prst="rect">
+            <a:avLst/>
+          </a:prstGeom>
+          <a:noFill/>
+        </p:spPr>
+        <p:txBody>
+          <a:bodyPr wrap="none">
+            <a:spAutoFit/>
+          </a:bodyPr>
+          <a:lstStyle/>
           <a:p>
             <a:r>
               <a:rPr sz="1800"/>
-              <a:t>Synthetic microscopy: defect density varies by position.</a:t>
+              <a:t>Synthetic microscopy shows position-dependent defect density.</a:t>
             </a:r>
           </a:p>
           <a:p/>
           <a:p>
             <a:r>
               <a:rPr sz="1800"/>
-              <a:t>Test transport versus boundary accumulation.</a:t>
+              <a:t>The spatial trend is not explained by the current process model.</a:t>
             </a:r>
           </a:p>
         </p:txBody>
       </p:sp>
       <p:pic>
         <p:nvPicPr>
-          <p:cNvPr id="4" name="Picture 3" descr="observation_visual.png"/>
+          <p:cNvPr id="5" name="Picture 4" descr="observation_visual.png"/>
           <p:cNvPicPr>
             <a:picLocks noChangeAspect="1"/>
           </p:cNvPicPr>
@@ -3804,7 +3828,7 @@
 </file>
 
 <file path=ppt/slides/slide4.xml><?xml version="1.0" encoding="utf-8"?>
-<p:sld xmlns:a="http://schemas.openxmlformats.org/drawingml/2006/main" xmlns:p="http://schemas.openxmlformats.org/presentationml/2006/main" xmlns:r="http://schemas.openxmlformats.org/officeDocument/2006/relationships">
+<p:sld xmlns:a="http://schemas.openxmlformats.org/drawingml/2006/main" xmlns:ns3="http://schemas.microsoft.com/office/drawing/2016/SVG/main" xmlns:p="http://schemas.openxmlformats.org/presentationml/2006/main" xmlns:r="http://schemas.openxmlformats.org/officeDocument/2006/relationships">
   <p:cSld>
     <p:spTree>
       <p:nvGrpSpPr>
@@ -3848,6 +3872,30 @@
         <p:txBody>
           <a:bodyPr/>
           <a:lstStyle/>
+          <a:p/>
+        </p:txBody>
+      </p:sp>
+      <p:sp>
+        <p:nvSpPr>
+          <p:cNvPr id="4" name="TextBox 3"/>
+          <p:cNvSpPr txBox="1"/>
+          <p:nvPr/>
+        </p:nvSpPr>
+        <p:spPr>
+          <a:xfrm>
+            <a:off x="640080" y="1371600"/>
+            <a:ext cx="4023360" cy="4389120"/>
+          </a:xfrm>
+          <a:prstGeom prst="rect">
+            <a:avLst/>
+          </a:prstGeom>
+          <a:noFill/>
+        </p:spPr>
+        <p:txBody>
+          <a:bodyPr wrap="none">
+            <a:spAutoFit/>
+          </a:bodyPr>
+          <a:lstStyle/>
           <a:p>
             <a:r>
               <a:rPr sz="1600"/>
@@ -3857,33 +3905,39 @@
           <a:p>
             <a:r>
               <a:rPr sz="1600"/>
-              <a:t>Trend supports transport, but boundary effects remain unresolved.</a:t>
+              <a:t>The gradient supports the transport hypothesis, but does not discriminate boundary effects.</a:t>
             </a:r>
           </a:p>
           <a:p>
             <a:r>
               <a:rPr sz="1600"/>
-              <a:t>Decision: Partial-Go: add control</a:t>
+              <a:t>Decision: Trend supports the mechanism but a control is missing.</a:t>
             </a:r>
           </a:p>
           <a:p>
             <a:r>
               <a:rPr sz="1600"/>
-              <a:t>Next Step: Tracer control; researcher; due 2026-09-02</a:t>
+              <a:t>Next Step: Run synthetic position comparison</a:t>
             </a:r>
           </a:p>
         </p:txBody>
       </p:sp>
       <p:pic>
         <p:nvPicPr>
-          <p:cNvPr id="4" name="Picture 3" descr="B001_defect_density.png"/>
+          <p:cNvPr id="5" name="Picture 4" descr="B001_defect_density.png"/>
           <p:cNvPicPr>
             <a:picLocks noChangeAspect="1"/>
           </p:cNvPicPr>
           <p:nvPr/>
         </p:nvPicPr>
         <p:blipFill>
-          <a:blip r:embed="rId2"/>
+          <a:blip r:embed="rId2">
+            <a:extLst>
+              <a:ext uri="{96DAC541-7B7A-43D3-8B79-37D633B846F1}">
+                <ns3:svgBlip r:embed="rId99"/>
+              </a:ext>
+            </a:extLst>
+          </a:blip>
           <a:stretch>
             <a:fillRect/>
           </a:stretch>

</xml_diff>

<commit_message>
fix: resolve Phase 1 revision 3 blockers
</commit_message>
<xml_diff>
--- a/thesis-deck-system/artifacts/phase1/master_first_build.pptx
+++ b/thesis-deck-system/artifacts/phase1/master_first_build.pptx
@@ -510,12 +510,17 @@
           </a:p>
           <a:p>
             <a:r>
-              <a:t>Synthetic fixture: E001</a:t>
+              <a:t>E002</a:t>
             </a:r>
           </a:p>
           <a:p>
             <a:r>
               <a:t>[/Sources]</a:t>
+            </a:r>
+          </a:p>
+          <a:p>
+            <a:r>
+              <a:t>Synthetic fixture — verify evidence provenance.</a:t>
             </a:r>
           </a:p>
         </p:txBody>
@@ -590,12 +595,22 @@
           </a:p>
           <a:p>
             <a:r>
-              <a:t>Synthetic fixture: E001</a:t>
+              <a:t>E001</a:t>
+            </a:r>
+          </a:p>
+          <a:p>
+            <a:r>
+              <a:t>E003</a:t>
             </a:r>
           </a:p>
           <a:p>
             <a:r>
               <a:t>[/Sources]</a:t>
+            </a:r>
+          </a:p>
+          <a:p>
+            <a:r>
+              <a:t>Synthetic fixture — verify evidence provenance.</a:t>
             </a:r>
           </a:p>
         </p:txBody>
@@ -3917,7 +3932,7 @@
           <a:p>
             <a:r>
               <a:rPr sz="1600"/>
-              <a:t>Next Step: Run synthetic position comparison</a:t>
+              <a:t>Next Step: Run synthetic position comparison; status planned; due 2026-09-02T09:00:00Z</a:t>
             </a:r>
           </a:p>
         </p:txBody>

</xml_diff>